<commit_message>
Refresh module 01 decks with the final series layout
Content-sized cards, steps and comparisons, vertically centered when
short, and fixed line breaks in mixed code/text labels.

Co-Authored-By: Claude Opus 5.5 <noreply@anthropic.com>
</commit_message>
<xml_diff>
--- a/modulo-01/01.01 - Iniciando a Jornada/01.01_ABAP_Cloud_Clean_Core_E_ADT.pptx
+++ b/modulo-01/01.01 - Iniciando a Jornada/01.01_ABAP_Cloud_Clean_Core_E_ADT.pptx
@@ -3431,7 +3431,7 @@
         </p:nvSpPr>
         <p:spPr>
           <a:xfrm>
-            <a:off x="548640" y="1645920"/>
+            <a:off x="548640" y="2359660"/>
             <a:ext cx="3545738" cy="2348992"/>
           </a:xfrm>
           <a:prstGeom prst="roundRect">
@@ -3465,7 +3465,7 @@
         </p:nvSpPr>
         <p:spPr>
           <a:xfrm>
-            <a:off x="749808" y="1847088"/>
+            <a:off x="749808" y="2560828"/>
             <a:ext cx="457200" cy="457200"/>
           </a:xfrm>
           <a:prstGeom prst="roundRect">
@@ -3487,7 +3487,7 @@
         </p:nvSpPr>
         <p:spPr>
           <a:xfrm>
-            <a:off x="2964180" y="1920240"/>
+            <a:off x="2964180" y="2633980"/>
             <a:ext cx="929030" cy="274320"/>
           </a:xfrm>
           <a:prstGeom prst="roundRect">
@@ -3509,7 +3509,7 @@
         </p:nvSpPr>
         <p:spPr>
           <a:xfrm>
-            <a:off x="2964180" y="1920240"/>
+            <a:off x="2964180" y="2633980"/>
             <a:ext cx="929030" cy="274320"/>
           </a:xfrm>
           <a:prstGeom prst="rect">
@@ -3545,7 +3545,7 @@
         </p:nvSpPr>
         <p:spPr>
           <a:xfrm>
-            <a:off x="749808" y="2450592"/>
+            <a:off x="749808" y="3164332"/>
             <a:ext cx="3143402" cy="1434592"/>
           </a:xfrm>
           <a:prstGeom prst="rect">
@@ -3671,7 +3671,7 @@
         </p:nvSpPr>
         <p:spPr>
           <a:xfrm>
-            <a:off x="4322978" y="1645920"/>
+            <a:off x="4322978" y="2359660"/>
             <a:ext cx="3545738" cy="2348992"/>
           </a:xfrm>
           <a:prstGeom prst="roundRect">
@@ -3705,7 +3705,7 @@
         </p:nvSpPr>
         <p:spPr>
           <a:xfrm>
-            <a:off x="4524146" y="1847088"/>
+            <a:off x="4524146" y="2560828"/>
             <a:ext cx="457200" cy="457200"/>
           </a:xfrm>
           <a:prstGeom prst="roundRect">
@@ -3727,7 +3727,7 @@
         </p:nvSpPr>
         <p:spPr>
           <a:xfrm>
-            <a:off x="6738518" y="1920240"/>
+            <a:off x="6738518" y="2633980"/>
             <a:ext cx="929030" cy="274320"/>
           </a:xfrm>
           <a:prstGeom prst="roundRect">
@@ -3749,7 +3749,7 @@
         </p:nvSpPr>
         <p:spPr>
           <a:xfrm>
-            <a:off x="6738518" y="1920240"/>
+            <a:off x="6738518" y="2633980"/>
             <a:ext cx="929030" cy="274320"/>
           </a:xfrm>
           <a:prstGeom prst="rect">
@@ -3785,7 +3785,7 @@
         </p:nvSpPr>
         <p:spPr>
           <a:xfrm>
-            <a:off x="4524146" y="2450592"/>
+            <a:off x="4524146" y="3164332"/>
             <a:ext cx="3143402" cy="1434592"/>
           </a:xfrm>
           <a:prstGeom prst="rect">
@@ -3854,7 +3854,7 @@
         </p:nvSpPr>
         <p:spPr>
           <a:xfrm>
-            <a:off x="8097317" y="1645920"/>
+            <a:off x="8097317" y="2359660"/>
             <a:ext cx="3545738" cy="2348992"/>
           </a:xfrm>
           <a:prstGeom prst="roundRect">
@@ -3888,7 +3888,7 @@
         </p:nvSpPr>
         <p:spPr>
           <a:xfrm>
-            <a:off x="8298485" y="1847088"/>
+            <a:off x="8298485" y="2560828"/>
             <a:ext cx="457200" cy="457200"/>
           </a:xfrm>
           <a:prstGeom prst="roundRect">
@@ -3910,7 +3910,7 @@
         </p:nvSpPr>
         <p:spPr>
           <a:xfrm>
-            <a:off x="10512857" y="1920240"/>
+            <a:off x="10512857" y="2633980"/>
             <a:ext cx="929030" cy="274320"/>
           </a:xfrm>
           <a:prstGeom prst="roundRect">
@@ -3932,7 +3932,7 @@
         </p:nvSpPr>
         <p:spPr>
           <a:xfrm>
-            <a:off x="10512857" y="1920240"/>
+            <a:off x="10512857" y="2633980"/>
             <a:ext cx="929030" cy="274320"/>
           </a:xfrm>
           <a:prstGeom prst="rect">
@@ -3968,7 +3968,7 @@
         </p:nvSpPr>
         <p:spPr>
           <a:xfrm>
-            <a:off x="8298485" y="2450592"/>
+            <a:off x="8298485" y="3164332"/>
             <a:ext cx="3143402" cy="1434592"/>
           </a:xfrm>
           <a:prstGeom prst="rect">
@@ -4040,7 +4040,7 @@
         </p:nvSpPr>
         <p:spPr>
           <a:xfrm>
-            <a:off x="548640" y="4177792"/>
+            <a:off x="548640" y="4891532"/>
             <a:ext cx="11094415" cy="566928"/>
           </a:xfrm>
           <a:prstGeom prst="roundRect">
@@ -4062,7 +4062,7 @@
         </p:nvSpPr>
         <p:spPr>
           <a:xfrm>
-            <a:off x="1207008" y="4177792"/>
+            <a:off x="1207008" y="4891532"/>
             <a:ext cx="10225735" cy="566928"/>
           </a:xfrm>
           <a:prstGeom prst="rect">
@@ -4114,7 +4114,7 @@
         </p:blipFill>
         <p:spPr>
           <a:xfrm>
-            <a:off x="4624730" y="1947672"/>
+            <a:off x="850392" y="2661412"/>
             <a:ext cx="256032" cy="256032"/>
           </a:xfrm>
           <a:prstGeom prst="rect">
@@ -4138,7 +4138,7 @@
         </p:blipFill>
         <p:spPr>
           <a:xfrm>
-            <a:off x="850392" y="1947672"/>
+            <a:off x="4624730" y="2661412"/>
             <a:ext cx="256032" cy="256032"/>
           </a:xfrm>
           <a:prstGeom prst="rect">
@@ -4162,7 +4162,7 @@
         </p:blipFill>
         <p:spPr>
           <a:xfrm>
-            <a:off x="8399069" y="1947672"/>
+            <a:off x="8399069" y="2661412"/>
             <a:ext cx="256032" cy="256032"/>
           </a:xfrm>
           <a:prstGeom prst="rect">
@@ -4186,7 +4186,7 @@
         </p:blipFill>
         <p:spPr>
           <a:xfrm>
-            <a:off x="749808" y="4305808"/>
+            <a:off x="749808" y="5019548"/>
             <a:ext cx="310896" cy="310896"/>
           </a:xfrm>
           <a:prstGeom prst="rect">
@@ -7117,7 +7117,7 @@
         </p:blipFill>
         <p:spPr>
           <a:xfrm>
-            <a:off x="7351205" y="2084832"/>
+            <a:off x="4474731" y="2084832"/>
             <a:ext cx="365760" cy="365760"/>
           </a:xfrm>
           <a:prstGeom prst="rect">
@@ -7141,7 +7141,7 @@
         </p:blipFill>
         <p:spPr>
           <a:xfrm>
-            <a:off x="4474731" y="2084832"/>
+            <a:off x="7351205" y="2084832"/>
             <a:ext cx="365760" cy="365760"/>
           </a:xfrm>
           <a:prstGeom prst="rect">
@@ -7165,8 +7165,8 @@
         </p:blipFill>
         <p:spPr>
           <a:xfrm>
-            <a:off x="10227678" y="2084832"/>
-            <a:ext cx="365760" cy="365760"/>
+            <a:off x="820034" y="3928994"/>
+            <a:ext cx="225308" cy="225308"/>
           </a:xfrm>
           <a:prstGeom prst="rect">
             <a:avLst/>
@@ -7189,7 +7189,7 @@
         </p:blipFill>
         <p:spPr>
           <a:xfrm>
-            <a:off x="820034" y="3928994"/>
+            <a:off x="4594372" y="3928994"/>
             <a:ext cx="225308" cy="225308"/>
           </a:xfrm>
           <a:prstGeom prst="rect">
@@ -7213,8 +7213,8 @@
         </p:blipFill>
         <p:spPr>
           <a:xfrm>
-            <a:off x="4594372" y="3928994"/>
-            <a:ext cx="225308" cy="225308"/>
+            <a:off x="10227678" y="2084832"/>
+            <a:ext cx="365760" cy="365760"/>
           </a:xfrm>
           <a:prstGeom prst="rect">
             <a:avLst/>
@@ -7399,7 +7399,7 @@
         </p:nvSpPr>
         <p:spPr>
           <a:xfrm>
-            <a:off x="1577614" y="1993392"/>
+            <a:off x="1577614" y="2441448"/>
             <a:ext cx="9036467" cy="0"/>
           </a:xfrm>
           <a:prstGeom prst="line">
@@ -7422,7 +7422,7 @@
         </p:nvSpPr>
         <p:spPr>
           <a:xfrm>
-            <a:off x="1230142" y="1645920"/>
+            <a:off x="1230142" y="2093976"/>
             <a:ext cx="694944" cy="694944"/>
           </a:xfrm>
           <a:prstGeom prst="ellipse">
@@ -7442,7 +7442,7 @@
         </p:nvSpPr>
         <p:spPr>
           <a:xfrm>
-            <a:off x="1230142" y="1645920"/>
+            <a:off x="1230142" y="2093976"/>
             <a:ext cx="694944" cy="694944"/>
           </a:xfrm>
           <a:prstGeom prst="rect">
@@ -7478,12 +7478,12 @@
         </p:nvSpPr>
         <p:spPr>
           <a:xfrm>
-            <a:off x="548640" y="2514600"/>
-            <a:ext cx="2057949" cy="2697480"/>
+            <a:off x="548640" y="2962656"/>
+            <a:ext cx="2057949" cy="2011680"/>
           </a:xfrm>
           <a:prstGeom prst="roundRect">
             <a:avLst>
-              <a:gd name="adj" fmla="val 4443"/>
+              <a:gd name="adj" fmla="val 4545"/>
             </a:avLst>
           </a:prstGeom>
           <a:solidFill>
@@ -7512,8 +7512,8 @@
         </p:nvSpPr>
         <p:spPr>
           <a:xfrm>
-            <a:off x="731520" y="2697480"/>
-            <a:ext cx="1280709" cy="2377440"/>
+            <a:off x="731520" y="3145536"/>
+            <a:ext cx="1280709" cy="1691640"/>
           </a:xfrm>
           <a:prstGeom prst="rect">
             <a:avLst/>
@@ -7581,7 +7581,7 @@
         </p:nvSpPr>
         <p:spPr>
           <a:xfrm>
-            <a:off x="3489259" y="1645920"/>
+            <a:off x="3489259" y="2093976"/>
             <a:ext cx="694944" cy="694944"/>
           </a:xfrm>
           <a:prstGeom prst="ellipse">
@@ -7601,7 +7601,7 @@
         </p:nvSpPr>
         <p:spPr>
           <a:xfrm>
-            <a:off x="3489259" y="1645920"/>
+            <a:off x="3489259" y="2093976"/>
             <a:ext cx="694944" cy="694944"/>
           </a:xfrm>
           <a:prstGeom prst="rect">
@@ -7637,12 +7637,12 @@
         </p:nvSpPr>
         <p:spPr>
           <a:xfrm>
-            <a:off x="2807757" y="2514600"/>
-            <a:ext cx="2057949" cy="2697480"/>
+            <a:off x="2807757" y="2962656"/>
+            <a:ext cx="2057949" cy="2011680"/>
           </a:xfrm>
           <a:prstGeom prst="roundRect">
             <a:avLst>
-              <a:gd name="adj" fmla="val 4443"/>
+              <a:gd name="adj" fmla="val 4545"/>
             </a:avLst>
           </a:prstGeom>
           <a:solidFill>
@@ -7671,8 +7671,8 @@
         </p:nvSpPr>
         <p:spPr>
           <a:xfrm>
-            <a:off x="2990637" y="2697480"/>
-            <a:ext cx="1280709" cy="2377440"/>
+            <a:off x="2990637" y="3145536"/>
+            <a:ext cx="1280709" cy="1691640"/>
           </a:xfrm>
           <a:prstGeom prst="rect">
             <a:avLst/>
@@ -7724,7 +7724,7 @@
         </p:nvSpPr>
         <p:spPr>
           <a:xfrm>
-            <a:off x="5748376" y="1645920"/>
+            <a:off x="5748376" y="2093976"/>
             <a:ext cx="694944" cy="694944"/>
           </a:xfrm>
           <a:prstGeom prst="ellipse">
@@ -7744,7 +7744,7 @@
         </p:nvSpPr>
         <p:spPr>
           <a:xfrm>
-            <a:off x="5748376" y="1645920"/>
+            <a:off x="5748376" y="2093976"/>
             <a:ext cx="694944" cy="694944"/>
           </a:xfrm>
           <a:prstGeom prst="rect">
@@ -7780,12 +7780,12 @@
         </p:nvSpPr>
         <p:spPr>
           <a:xfrm>
-            <a:off x="5066873" y="2514600"/>
-            <a:ext cx="2057949" cy="2697480"/>
+            <a:off x="5066873" y="2962656"/>
+            <a:ext cx="2057949" cy="2011680"/>
           </a:xfrm>
           <a:prstGeom prst="roundRect">
             <a:avLst>
-              <a:gd name="adj" fmla="val 4443"/>
+              <a:gd name="adj" fmla="val 4545"/>
             </a:avLst>
           </a:prstGeom>
           <a:solidFill>
@@ -7814,8 +7814,8 @@
         </p:nvSpPr>
         <p:spPr>
           <a:xfrm>
-            <a:off x="5249753" y="2697480"/>
-            <a:ext cx="1280709" cy="2377440"/>
+            <a:off x="5249753" y="3145536"/>
+            <a:ext cx="1280709" cy="1691640"/>
           </a:xfrm>
           <a:prstGeom prst="rect">
             <a:avLst/>
@@ -7867,7 +7867,7 @@
         </p:nvSpPr>
         <p:spPr>
           <a:xfrm>
-            <a:off x="8007492" y="1645920"/>
+            <a:off x="8007492" y="2093976"/>
             <a:ext cx="694944" cy="694944"/>
           </a:xfrm>
           <a:prstGeom prst="ellipse">
@@ -7887,7 +7887,7 @@
         </p:nvSpPr>
         <p:spPr>
           <a:xfrm>
-            <a:off x="8007492" y="1645920"/>
+            <a:off x="8007492" y="2093976"/>
             <a:ext cx="694944" cy="694944"/>
           </a:xfrm>
           <a:prstGeom prst="rect">
@@ -7923,12 +7923,12 @@
         </p:nvSpPr>
         <p:spPr>
           <a:xfrm>
-            <a:off x="7325990" y="2514600"/>
-            <a:ext cx="2057949" cy="2697480"/>
+            <a:off x="7325990" y="2962656"/>
+            <a:ext cx="2057949" cy="2011680"/>
           </a:xfrm>
           <a:prstGeom prst="roundRect">
             <a:avLst>
-              <a:gd name="adj" fmla="val 4443"/>
+              <a:gd name="adj" fmla="val 4545"/>
             </a:avLst>
           </a:prstGeom>
           <a:solidFill>
@@ -7957,8 +7957,8 @@
         </p:nvSpPr>
         <p:spPr>
           <a:xfrm>
-            <a:off x="7508870" y="2697480"/>
-            <a:ext cx="1280709" cy="2377440"/>
+            <a:off x="7508870" y="3145536"/>
+            <a:ext cx="1280709" cy="1691640"/>
           </a:xfrm>
           <a:prstGeom prst="rect">
             <a:avLst/>
@@ -8010,7 +8010,7 @@
         </p:nvSpPr>
         <p:spPr>
           <a:xfrm>
-            <a:off x="10266609" y="1645920"/>
+            <a:off x="10266609" y="2093976"/>
             <a:ext cx="694944" cy="694944"/>
           </a:xfrm>
           <a:prstGeom prst="ellipse">
@@ -8030,7 +8030,7 @@
         </p:nvSpPr>
         <p:spPr>
           <a:xfrm>
-            <a:off x="10266609" y="1645920"/>
+            <a:off x="10266609" y="2093976"/>
             <a:ext cx="694944" cy="694944"/>
           </a:xfrm>
           <a:prstGeom prst="rect">
@@ -8066,12 +8066,12 @@
         </p:nvSpPr>
         <p:spPr>
           <a:xfrm>
-            <a:off x="9585107" y="2514600"/>
-            <a:ext cx="2057949" cy="2697480"/>
+            <a:off x="9585107" y="2962656"/>
+            <a:ext cx="2057949" cy="2011680"/>
           </a:xfrm>
           <a:prstGeom prst="roundRect">
             <a:avLst>
-              <a:gd name="adj" fmla="val 4443"/>
+              <a:gd name="adj" fmla="val 4545"/>
             </a:avLst>
           </a:prstGeom>
           <a:solidFill>
@@ -8100,8 +8100,8 @@
         </p:nvSpPr>
         <p:spPr>
           <a:xfrm>
-            <a:off x="9767987" y="2697480"/>
-            <a:ext cx="1280709" cy="2377440"/>
+            <a:off x="9767987" y="3145536"/>
+            <a:ext cx="1280709" cy="1691640"/>
           </a:xfrm>
           <a:prstGeom prst="rect">
             <a:avLst/>
@@ -8153,7 +8153,7 @@
         </p:nvSpPr>
         <p:spPr>
           <a:xfrm>
-            <a:off x="548640" y="5394960"/>
+            <a:off x="548640" y="5157216"/>
             <a:ext cx="11094415" cy="566928"/>
           </a:xfrm>
           <a:prstGeom prst="roundRect">
@@ -8175,7 +8175,7 @@
         </p:nvSpPr>
         <p:spPr>
           <a:xfrm>
-            <a:off x="1207008" y="5394960"/>
+            <a:off x="1207008" y="5157216"/>
             <a:ext cx="10225735" cy="566928"/>
           </a:xfrm>
           <a:prstGeom prst="rect">
@@ -8227,7 +8227,7 @@
         </p:blipFill>
         <p:spPr>
           <a:xfrm>
-            <a:off x="2057949" y="2670048"/>
+            <a:off x="2057949" y="3118104"/>
             <a:ext cx="329184" cy="329184"/>
           </a:xfrm>
           <a:prstGeom prst="rect">
@@ -8251,7 +8251,7 @@
         </p:blipFill>
         <p:spPr>
           <a:xfrm>
-            <a:off x="6576182" y="2670048"/>
+            <a:off x="4317065" y="3118104"/>
             <a:ext cx="329184" cy="329184"/>
           </a:xfrm>
           <a:prstGeom prst="rect">
@@ -8275,7 +8275,7 @@
         </p:blipFill>
         <p:spPr>
           <a:xfrm>
-            <a:off x="8835299" y="2670048"/>
+            <a:off x="6576182" y="3118104"/>
             <a:ext cx="329184" cy="329184"/>
           </a:xfrm>
           <a:prstGeom prst="rect">
@@ -8299,7 +8299,7 @@
         </p:blipFill>
         <p:spPr>
           <a:xfrm>
-            <a:off x="4317065" y="2670048"/>
+            <a:off x="8835299" y="3118104"/>
             <a:ext cx="329184" cy="329184"/>
           </a:xfrm>
           <a:prstGeom prst="rect">
@@ -8323,7 +8323,7 @@
         </p:blipFill>
         <p:spPr>
           <a:xfrm>
-            <a:off x="11094415" y="2670048"/>
+            <a:off x="11094415" y="3118104"/>
             <a:ext cx="329184" cy="329184"/>
           </a:xfrm>
           <a:prstGeom prst="rect">
@@ -8347,7 +8347,7 @@
         </p:blipFill>
         <p:spPr>
           <a:xfrm>
-            <a:off x="749808" y="5522976"/>
+            <a:off x="749808" y="5285232"/>
             <a:ext cx="310896" cy="310896"/>
           </a:xfrm>
           <a:prstGeom prst="rect">
@@ -11112,7 +11112,7 @@
         </p:nvSpPr>
         <p:spPr>
           <a:xfrm>
-            <a:off x="1577614" y="1993392"/>
+            <a:off x="1577614" y="2848356"/>
             <a:ext cx="9036467" cy="0"/>
           </a:xfrm>
           <a:prstGeom prst="line">
@@ -11135,7 +11135,7 @@
         </p:nvSpPr>
         <p:spPr>
           <a:xfrm>
-            <a:off x="1230142" y="1645920"/>
+            <a:off x="1230142" y="2500884"/>
             <a:ext cx="694944" cy="694944"/>
           </a:xfrm>
           <a:prstGeom prst="ellipse">
@@ -11155,7 +11155,7 @@
         </p:nvSpPr>
         <p:spPr>
           <a:xfrm>
-            <a:off x="1230142" y="1645920"/>
+            <a:off x="1230142" y="2500884"/>
             <a:ext cx="694944" cy="694944"/>
           </a:xfrm>
           <a:prstGeom prst="rect">
@@ -11191,12 +11191,12 @@
         </p:nvSpPr>
         <p:spPr>
           <a:xfrm>
-            <a:off x="548640" y="2514600"/>
-            <a:ext cx="2057949" cy="3337560"/>
+            <a:off x="548640" y="3369564"/>
+            <a:ext cx="2057949" cy="1947672"/>
           </a:xfrm>
           <a:prstGeom prst="roundRect">
             <a:avLst>
-              <a:gd name="adj" fmla="val 4443"/>
+              <a:gd name="adj" fmla="val 4695"/>
             </a:avLst>
           </a:prstGeom>
           <a:solidFill>
@@ -11225,8 +11225,8 @@
         </p:nvSpPr>
         <p:spPr>
           <a:xfrm>
-            <a:off x="731520" y="2697480"/>
-            <a:ext cx="1280709" cy="3017520"/>
+            <a:off x="731520" y="3552444"/>
+            <a:ext cx="1280709" cy="1627632"/>
           </a:xfrm>
           <a:prstGeom prst="rect">
             <a:avLst/>
@@ -11297,7 +11297,7 @@
         </p:nvSpPr>
         <p:spPr>
           <a:xfrm>
-            <a:off x="3489259" y="1645920"/>
+            <a:off x="3489259" y="2500884"/>
             <a:ext cx="694944" cy="694944"/>
           </a:xfrm>
           <a:prstGeom prst="ellipse">
@@ -11317,7 +11317,7 @@
         </p:nvSpPr>
         <p:spPr>
           <a:xfrm>
-            <a:off x="3489259" y="1645920"/>
+            <a:off x="3489259" y="2500884"/>
             <a:ext cx="694944" cy="694944"/>
           </a:xfrm>
           <a:prstGeom prst="rect">
@@ -11353,12 +11353,12 @@
         </p:nvSpPr>
         <p:spPr>
           <a:xfrm>
-            <a:off x="2807757" y="2514600"/>
-            <a:ext cx="2057949" cy="3337560"/>
+            <a:off x="2807757" y="3369564"/>
+            <a:ext cx="2057949" cy="1947672"/>
           </a:xfrm>
           <a:prstGeom prst="roundRect">
             <a:avLst>
-              <a:gd name="adj" fmla="val 4443"/>
+              <a:gd name="adj" fmla="val 4695"/>
             </a:avLst>
           </a:prstGeom>
           <a:solidFill>
@@ -11387,8 +11387,8 @@
         </p:nvSpPr>
         <p:spPr>
           <a:xfrm>
-            <a:off x="2990637" y="2697480"/>
-            <a:ext cx="1280709" cy="3017520"/>
+            <a:off x="2990637" y="3552444"/>
+            <a:ext cx="1280709" cy="1627632"/>
           </a:xfrm>
           <a:prstGeom prst="rect">
             <a:avLst/>
@@ -11475,7 +11475,7 @@
         </p:nvSpPr>
         <p:spPr>
           <a:xfrm>
-            <a:off x="5748376" y="1645920"/>
+            <a:off x="5748376" y="2500884"/>
             <a:ext cx="694944" cy="694944"/>
           </a:xfrm>
           <a:prstGeom prst="ellipse">
@@ -11495,7 +11495,7 @@
         </p:nvSpPr>
         <p:spPr>
           <a:xfrm>
-            <a:off x="5748376" y="1645920"/>
+            <a:off x="5748376" y="2500884"/>
             <a:ext cx="694944" cy="694944"/>
           </a:xfrm>
           <a:prstGeom prst="rect">
@@ -11531,12 +11531,12 @@
         </p:nvSpPr>
         <p:spPr>
           <a:xfrm>
-            <a:off x="5066873" y="2514600"/>
-            <a:ext cx="2057949" cy="3337560"/>
+            <a:off x="5066873" y="3369564"/>
+            <a:ext cx="2057949" cy="1947672"/>
           </a:xfrm>
           <a:prstGeom prst="roundRect">
             <a:avLst>
-              <a:gd name="adj" fmla="val 4443"/>
+              <a:gd name="adj" fmla="val 4695"/>
             </a:avLst>
           </a:prstGeom>
           <a:solidFill>
@@ -11565,8 +11565,8 @@
         </p:nvSpPr>
         <p:spPr>
           <a:xfrm>
-            <a:off x="5249753" y="2697480"/>
-            <a:ext cx="1280709" cy="3017520"/>
+            <a:off x="5249753" y="3552444"/>
+            <a:ext cx="1280709" cy="1627632"/>
           </a:xfrm>
           <a:prstGeom prst="rect">
             <a:avLst/>
@@ -11645,7 +11645,7 @@
         </p:nvSpPr>
         <p:spPr>
           <a:xfrm>
-            <a:off x="8007492" y="1645920"/>
+            <a:off x="8007492" y="2500884"/>
             <a:ext cx="694944" cy="694944"/>
           </a:xfrm>
           <a:prstGeom prst="ellipse">
@@ -11665,7 +11665,7 @@
         </p:nvSpPr>
         <p:spPr>
           <a:xfrm>
-            <a:off x="8007492" y="1645920"/>
+            <a:off x="8007492" y="2500884"/>
             <a:ext cx="694944" cy="694944"/>
           </a:xfrm>
           <a:prstGeom prst="rect">
@@ -11701,12 +11701,12 @@
         </p:nvSpPr>
         <p:spPr>
           <a:xfrm>
-            <a:off x="7325990" y="2514600"/>
-            <a:ext cx="2057949" cy="3337560"/>
+            <a:off x="7325990" y="3369564"/>
+            <a:ext cx="2057949" cy="1947672"/>
           </a:xfrm>
           <a:prstGeom prst="roundRect">
             <a:avLst>
-              <a:gd name="adj" fmla="val 4443"/>
+              <a:gd name="adj" fmla="val 4695"/>
             </a:avLst>
           </a:prstGeom>
           <a:solidFill>
@@ -11735,8 +11735,8 @@
         </p:nvSpPr>
         <p:spPr>
           <a:xfrm>
-            <a:off x="7508870" y="2697480"/>
-            <a:ext cx="1280709" cy="3017520"/>
+            <a:off x="7508870" y="3552444"/>
+            <a:ext cx="1280709" cy="1627632"/>
           </a:xfrm>
           <a:prstGeom prst="rect">
             <a:avLst/>
@@ -11799,7 +11799,7 @@
         </p:nvSpPr>
         <p:spPr>
           <a:xfrm>
-            <a:off x="10266609" y="1645920"/>
+            <a:off x="10266609" y="2500884"/>
             <a:ext cx="694944" cy="694944"/>
           </a:xfrm>
           <a:prstGeom prst="ellipse">
@@ -11819,7 +11819,7 @@
         </p:nvSpPr>
         <p:spPr>
           <a:xfrm>
-            <a:off x="10266609" y="1645920"/>
+            <a:off x="10266609" y="2500884"/>
             <a:ext cx="694944" cy="694944"/>
           </a:xfrm>
           <a:prstGeom prst="rect">
@@ -11855,12 +11855,12 @@
         </p:nvSpPr>
         <p:spPr>
           <a:xfrm>
-            <a:off x="9585107" y="2514600"/>
-            <a:ext cx="2057949" cy="3337560"/>
+            <a:off x="9585107" y="3369564"/>
+            <a:ext cx="2057949" cy="1947672"/>
           </a:xfrm>
           <a:prstGeom prst="roundRect">
             <a:avLst>
-              <a:gd name="adj" fmla="val 4443"/>
+              <a:gd name="adj" fmla="val 4695"/>
             </a:avLst>
           </a:prstGeom>
           <a:solidFill>
@@ -11889,8 +11889,8 @@
         </p:nvSpPr>
         <p:spPr>
           <a:xfrm>
-            <a:off x="9767987" y="2697480"/>
-            <a:ext cx="1280709" cy="3017520"/>
+            <a:off x="9767987" y="3552444"/>
+            <a:ext cx="1280709" cy="1627632"/>
           </a:xfrm>
           <a:prstGeom prst="rect">
             <a:avLst/>
@@ -11977,7 +11977,7 @@
         </p:blipFill>
         <p:spPr>
           <a:xfrm>
-            <a:off x="2057949" y="2670048"/>
+            <a:off x="2057949" y="3525012"/>
             <a:ext cx="329184" cy="329184"/>
           </a:xfrm>
           <a:prstGeom prst="rect">
@@ -12001,7 +12001,7 @@
         </p:blipFill>
         <p:spPr>
           <a:xfrm>
-            <a:off x="4317065" y="2670048"/>
+            <a:off x="4317065" y="3525012"/>
             <a:ext cx="329184" cy="329184"/>
           </a:xfrm>
           <a:prstGeom prst="rect">
@@ -12025,7 +12025,7 @@
         </p:blipFill>
         <p:spPr>
           <a:xfrm>
-            <a:off x="6576182" y="2670048"/>
+            <a:off x="6576182" y="3525012"/>
             <a:ext cx="329184" cy="329184"/>
           </a:xfrm>
           <a:prstGeom prst="rect">
@@ -12049,7 +12049,7 @@
         </p:blipFill>
         <p:spPr>
           <a:xfrm>
-            <a:off x="11094415" y="2670048"/>
+            <a:off x="8835299" y="3525012"/>
             <a:ext cx="329184" cy="329184"/>
           </a:xfrm>
           <a:prstGeom prst="rect">
@@ -12073,7 +12073,7 @@
         </p:blipFill>
         <p:spPr>
           <a:xfrm>
-            <a:off x="8835299" y="2670048"/>
+            <a:off x="11094415" y="3525012"/>
             <a:ext cx="329184" cy="329184"/>
           </a:xfrm>
           <a:prstGeom prst="rect">
@@ -12676,7 +12676,7 @@
         </p:nvSpPr>
         <p:spPr>
           <a:xfrm>
-            <a:off x="548640" y="1645920"/>
+            <a:off x="548640" y="2255520"/>
             <a:ext cx="2602154" cy="2557272"/>
           </a:xfrm>
           <a:prstGeom prst="roundRect">
@@ -12710,7 +12710,7 @@
         </p:nvSpPr>
         <p:spPr>
           <a:xfrm>
-            <a:off x="749808" y="1847088"/>
+            <a:off x="749808" y="2456688"/>
             <a:ext cx="457200" cy="457200"/>
           </a:xfrm>
           <a:prstGeom prst="roundRect">
@@ -12732,7 +12732,7 @@
         </p:nvSpPr>
         <p:spPr>
           <a:xfrm>
-            <a:off x="749808" y="2450592"/>
+            <a:off x="749808" y="3060192"/>
             <a:ext cx="2199818" cy="1642872"/>
           </a:xfrm>
           <a:prstGeom prst="rect">
@@ -12804,7 +12804,7 @@
         </p:nvSpPr>
         <p:spPr>
           <a:xfrm>
-            <a:off x="3379394" y="1645920"/>
+            <a:off x="3379394" y="2255520"/>
             <a:ext cx="2602154" cy="2557272"/>
           </a:xfrm>
           <a:prstGeom prst="roundRect">
@@ -12838,7 +12838,7 @@
         </p:nvSpPr>
         <p:spPr>
           <a:xfrm>
-            <a:off x="3580562" y="1847088"/>
+            <a:off x="3580562" y="2456688"/>
             <a:ext cx="457200" cy="457200"/>
           </a:xfrm>
           <a:prstGeom prst="roundRect">
@@ -12860,7 +12860,7 @@
         </p:nvSpPr>
         <p:spPr>
           <a:xfrm>
-            <a:off x="3580562" y="2450592"/>
+            <a:off x="3580562" y="3060192"/>
             <a:ext cx="2199818" cy="1642872"/>
           </a:xfrm>
           <a:prstGeom prst="rect">
@@ -12929,7 +12929,7 @@
         </p:nvSpPr>
         <p:spPr>
           <a:xfrm>
-            <a:off x="6210148" y="1645920"/>
+            <a:off x="6210148" y="2255520"/>
             <a:ext cx="2602154" cy="2557272"/>
           </a:xfrm>
           <a:prstGeom prst="roundRect">
@@ -12963,7 +12963,7 @@
         </p:nvSpPr>
         <p:spPr>
           <a:xfrm>
-            <a:off x="6411316" y="1847088"/>
+            <a:off x="6411316" y="2456688"/>
             <a:ext cx="457200" cy="457200"/>
           </a:xfrm>
           <a:prstGeom prst="roundRect">
@@ -12985,7 +12985,7 @@
         </p:nvSpPr>
         <p:spPr>
           <a:xfrm>
-            <a:off x="6411316" y="2450592"/>
+            <a:off x="6411316" y="3060192"/>
             <a:ext cx="2199818" cy="1642872"/>
           </a:xfrm>
           <a:prstGeom prst="rect">
@@ -13054,7 +13054,7 @@
         </p:nvSpPr>
         <p:spPr>
           <a:xfrm>
-            <a:off x="9040901" y="1645920"/>
+            <a:off x="9040901" y="2255520"/>
             <a:ext cx="2602154" cy="2557272"/>
           </a:xfrm>
           <a:prstGeom prst="roundRect">
@@ -13088,7 +13088,7 @@
         </p:nvSpPr>
         <p:spPr>
           <a:xfrm>
-            <a:off x="9242069" y="1847088"/>
+            <a:off x="9242069" y="2456688"/>
             <a:ext cx="457200" cy="457200"/>
           </a:xfrm>
           <a:prstGeom prst="roundRect">
@@ -13110,7 +13110,7 @@
         </p:nvSpPr>
         <p:spPr>
           <a:xfrm>
-            <a:off x="9242069" y="2450592"/>
+            <a:off x="9242069" y="3060192"/>
             <a:ext cx="2199818" cy="1642872"/>
           </a:xfrm>
           <a:prstGeom prst="rect">
@@ -13163,7 +13163,7 @@
         </p:nvSpPr>
         <p:spPr>
           <a:xfrm>
-            <a:off x="548640" y="4386072"/>
+            <a:off x="548640" y="4995672"/>
             <a:ext cx="11094415" cy="566928"/>
           </a:xfrm>
           <a:prstGeom prst="roundRect">
@@ -13185,7 +13185,7 @@
         </p:nvSpPr>
         <p:spPr>
           <a:xfrm>
-            <a:off x="1207008" y="4386072"/>
+            <a:off x="1207008" y="4995672"/>
             <a:ext cx="10225735" cy="566928"/>
           </a:xfrm>
           <a:prstGeom prst="rect">
@@ -13237,7 +13237,7 @@
         </p:blipFill>
         <p:spPr>
           <a:xfrm>
-            <a:off x="850392" y="1947672"/>
+            <a:off x="3681146" y="2557272"/>
             <a:ext cx="256032" cy="256032"/>
           </a:xfrm>
           <a:prstGeom prst="rect">
@@ -13261,7 +13261,7 @@
         </p:blipFill>
         <p:spPr>
           <a:xfrm>
-            <a:off x="3681146" y="1947672"/>
+            <a:off x="850392" y="2557272"/>
             <a:ext cx="256032" cy="256032"/>
           </a:xfrm>
           <a:prstGeom prst="rect">
@@ -13285,7 +13285,7 @@
         </p:blipFill>
         <p:spPr>
           <a:xfrm>
-            <a:off x="6511900" y="1947672"/>
+            <a:off x="6511900" y="2557272"/>
             <a:ext cx="256032" cy="256032"/>
           </a:xfrm>
           <a:prstGeom prst="rect">
@@ -13309,7 +13309,7 @@
         </p:blipFill>
         <p:spPr>
           <a:xfrm>
-            <a:off x="9342653" y="1947672"/>
+            <a:off x="9342653" y="2557272"/>
             <a:ext cx="256032" cy="256032"/>
           </a:xfrm>
           <a:prstGeom prst="rect">
@@ -13333,7 +13333,7 @@
         </p:blipFill>
         <p:spPr>
           <a:xfrm>
-            <a:off x="749808" y="4514088"/>
+            <a:off x="749808" y="5123688"/>
             <a:ext cx="310896" cy="310896"/>
           </a:xfrm>
           <a:prstGeom prst="rect">
@@ -14995,7 +14995,7 @@
         </p:blipFill>
         <p:spPr>
           <a:xfrm>
-            <a:off x="2636444" y="3858768"/>
+            <a:off x="11094415" y="1847088"/>
             <a:ext cx="347472" cy="347472"/>
           </a:xfrm>
           <a:prstGeom prst="rect">
@@ -15019,7 +15019,7 @@
         </p:blipFill>
         <p:spPr>
           <a:xfrm>
-            <a:off x="11094415" y="1847088"/>
+            <a:off x="2636444" y="3858768"/>
             <a:ext cx="347472" cy="347472"/>
           </a:xfrm>
           <a:prstGeom prst="rect">
@@ -15888,7 +15888,7 @@
         </p:blipFill>
         <p:spPr>
           <a:xfrm>
-            <a:off x="6355080" y="2926080"/>
+            <a:off x="822960" y="2926080"/>
             <a:ext cx="256032" cy="256032"/>
           </a:xfrm>
           <a:prstGeom prst="rect">
@@ -15912,7 +15912,7 @@
         </p:blipFill>
         <p:spPr>
           <a:xfrm>
-            <a:off x="822960" y="2926080"/>
+            <a:off x="6355080" y="2926080"/>
             <a:ext cx="256032" cy="256032"/>
           </a:xfrm>
           <a:prstGeom prst="rect">
@@ -17819,7 +17819,7 @@
         </p:nvSpPr>
         <p:spPr>
           <a:xfrm>
-            <a:off x="548640" y="1645920"/>
+            <a:off x="548640" y="2359660"/>
             <a:ext cx="3545738" cy="2348992"/>
           </a:xfrm>
           <a:prstGeom prst="roundRect">
@@ -17853,7 +17853,7 @@
         </p:nvSpPr>
         <p:spPr>
           <a:xfrm>
-            <a:off x="749808" y="1847088"/>
+            <a:off x="749808" y="2560828"/>
             <a:ext cx="457200" cy="457200"/>
           </a:xfrm>
           <a:prstGeom prst="roundRect">
@@ -17875,7 +17875,7 @@
         </p:nvSpPr>
         <p:spPr>
           <a:xfrm>
-            <a:off x="749808" y="2450592"/>
+            <a:off x="749808" y="3164332"/>
             <a:ext cx="3143402" cy="1434592"/>
           </a:xfrm>
           <a:prstGeom prst="rect">
@@ -17960,7 +17960,7 @@
         </p:nvSpPr>
         <p:spPr>
           <a:xfrm>
-            <a:off x="4322978" y="1645920"/>
+            <a:off x="4322978" y="2359660"/>
             <a:ext cx="3545738" cy="2348992"/>
           </a:xfrm>
           <a:prstGeom prst="roundRect">
@@ -17994,7 +17994,7 @@
         </p:nvSpPr>
         <p:spPr>
           <a:xfrm>
-            <a:off x="4524146" y="1847088"/>
+            <a:off x="4524146" y="2560828"/>
             <a:ext cx="457200" cy="457200"/>
           </a:xfrm>
           <a:prstGeom prst="roundRect">
@@ -18016,7 +18016,7 @@
         </p:nvSpPr>
         <p:spPr>
           <a:xfrm>
-            <a:off x="4524146" y="2450592"/>
+            <a:off x="4524146" y="3164332"/>
             <a:ext cx="3143402" cy="1434592"/>
           </a:xfrm>
           <a:prstGeom prst="rect">
@@ -18101,7 +18101,7 @@
         </p:nvSpPr>
         <p:spPr>
           <a:xfrm>
-            <a:off x="8097317" y="1645920"/>
+            <a:off x="8097317" y="2359660"/>
             <a:ext cx="3545738" cy="2348992"/>
           </a:xfrm>
           <a:prstGeom prst="roundRect">
@@ -18135,7 +18135,7 @@
         </p:nvSpPr>
         <p:spPr>
           <a:xfrm>
-            <a:off x="8298485" y="1847088"/>
+            <a:off x="8298485" y="2560828"/>
             <a:ext cx="457200" cy="457200"/>
           </a:xfrm>
           <a:prstGeom prst="roundRect">
@@ -18157,7 +18157,7 @@
         </p:nvSpPr>
         <p:spPr>
           <a:xfrm>
-            <a:off x="8298485" y="2450592"/>
+            <a:off x="8298485" y="3164332"/>
             <a:ext cx="3143402" cy="1434592"/>
           </a:xfrm>
           <a:prstGeom prst="rect">
@@ -18210,7 +18210,7 @@
         </p:nvSpPr>
         <p:spPr>
           <a:xfrm>
-            <a:off x="548640" y="4177792"/>
+            <a:off x="548640" y="4891532"/>
             <a:ext cx="11094415" cy="566928"/>
           </a:xfrm>
           <a:prstGeom prst="roundRect">
@@ -18232,7 +18232,7 @@
         </p:nvSpPr>
         <p:spPr>
           <a:xfrm>
-            <a:off x="1207008" y="4177792"/>
+            <a:off x="1207008" y="4891532"/>
             <a:ext cx="10225735" cy="566928"/>
           </a:xfrm>
           <a:prstGeom prst="rect">
@@ -18284,7 +18284,7 @@
         </p:blipFill>
         <p:spPr>
           <a:xfrm>
-            <a:off x="850392" y="1947672"/>
+            <a:off x="850392" y="2661412"/>
             <a:ext cx="256032" cy="256032"/>
           </a:xfrm>
           <a:prstGeom prst="rect">
@@ -18308,7 +18308,7 @@
         </p:blipFill>
         <p:spPr>
           <a:xfrm>
-            <a:off x="4624730" y="1947672"/>
+            <a:off x="4624730" y="2661412"/>
             <a:ext cx="256032" cy="256032"/>
           </a:xfrm>
           <a:prstGeom prst="rect">
@@ -18332,7 +18332,7 @@
         </p:blipFill>
         <p:spPr>
           <a:xfrm>
-            <a:off x="8399069" y="1947672"/>
+            <a:off x="8399069" y="2661412"/>
             <a:ext cx="256032" cy="256032"/>
           </a:xfrm>
           <a:prstGeom prst="rect">
@@ -18356,7 +18356,7 @@
         </p:blipFill>
         <p:spPr>
           <a:xfrm>
-            <a:off x="749808" y="4305808"/>
+            <a:off x="749808" y="5019548"/>
             <a:ext cx="310896" cy="310896"/>
           </a:xfrm>
           <a:prstGeom prst="rect">
@@ -19188,7 +19188,7 @@
         </p:blipFill>
         <p:spPr>
           <a:xfrm>
-            <a:off x="1598257" y="2084832"/>
+            <a:off x="7351205" y="2084832"/>
             <a:ext cx="365760" cy="365760"/>
           </a:xfrm>
           <a:prstGeom prst="rect">
@@ -19236,7 +19236,7 @@
         </p:blipFill>
         <p:spPr>
           <a:xfrm>
-            <a:off x="7351205" y="2084832"/>
+            <a:off x="1598257" y="2084832"/>
             <a:ext cx="365760" cy="365760"/>
           </a:xfrm>
           <a:prstGeom prst="rect">
@@ -19284,7 +19284,7 @@
         </p:blipFill>
         <p:spPr>
           <a:xfrm>
-            <a:off x="6481542" y="3928994"/>
+            <a:off x="820034" y="3928994"/>
             <a:ext cx="225308" cy="225308"/>
           </a:xfrm>
           <a:prstGeom prst="rect">
@@ -19308,7 +19308,7 @@
         </p:blipFill>
         <p:spPr>
           <a:xfrm>
-            <a:off x="820034" y="3928994"/>
+            <a:off x="6481542" y="3928994"/>
             <a:ext cx="225308" cy="225308"/>
           </a:xfrm>
           <a:prstGeom prst="rect">
@@ -20849,7 +20849,7 @@
         </p:blipFill>
         <p:spPr>
           <a:xfrm>
-            <a:off x="8165409" y="3718682"/>
+            <a:off x="8165409" y="1917314"/>
             <a:ext cx="225308" cy="225308"/>
           </a:xfrm>
           <a:prstGeom prst="rect">
@@ -20873,7 +20873,7 @@
         </p:blipFill>
         <p:spPr>
           <a:xfrm>
-            <a:off x="8165409" y="1917314"/>
+            <a:off x="8165409" y="3718682"/>
             <a:ext cx="225308" cy="225308"/>
           </a:xfrm>
           <a:prstGeom prst="rect">
@@ -21476,12 +21476,12 @@
         </p:nvSpPr>
         <p:spPr>
           <a:xfrm>
-            <a:off x="548640" y="1645920"/>
-            <a:ext cx="5410048" cy="4526280"/>
+            <a:off x="548640" y="2299430"/>
+            <a:ext cx="5410048" cy="3219260"/>
           </a:xfrm>
           <a:prstGeom prst="roundRect">
             <a:avLst>
-              <a:gd name="adj" fmla="val 2020"/>
+              <a:gd name="adj" fmla="val 2840"/>
             </a:avLst>
           </a:prstGeom>
           <a:solidFill>
@@ -21510,7 +21510,7 @@
         </p:nvSpPr>
         <p:spPr>
           <a:xfrm>
-            <a:off x="548640" y="1645920"/>
+            <a:off x="548640" y="2299430"/>
             <a:ext cx="5410048" cy="73152"/>
           </a:xfrm>
           <a:prstGeom prst="rect">
@@ -21530,7 +21530,7 @@
         </p:nvSpPr>
         <p:spPr>
           <a:xfrm>
-            <a:off x="777240" y="1920240"/>
+            <a:off x="777240" y="2573750"/>
             <a:ext cx="457200" cy="457200"/>
           </a:xfrm>
           <a:prstGeom prst="roundRect">
@@ -21552,7 +21552,7 @@
         </p:nvSpPr>
         <p:spPr>
           <a:xfrm>
-            <a:off x="1371600" y="1920240"/>
+            <a:off x="1371600" y="2573750"/>
             <a:ext cx="4404208" cy="457200"/>
           </a:xfrm>
           <a:prstGeom prst="rect">
@@ -21588,8 +21588,8 @@
         </p:nvSpPr>
         <p:spPr>
           <a:xfrm>
-            <a:off x="777240" y="2560320"/>
-            <a:ext cx="4952848" cy="3474720"/>
+            <a:off x="777240" y="3213830"/>
+            <a:ext cx="4952848" cy="2167700"/>
           </a:xfrm>
           <a:prstGeom prst="rect">
             <a:avLst/>
@@ -21720,12 +21720,12 @@
         </p:nvSpPr>
         <p:spPr>
           <a:xfrm>
-            <a:off x="6233008" y="1645920"/>
-            <a:ext cx="5410048" cy="4526280"/>
+            <a:off x="6233008" y="2299430"/>
+            <a:ext cx="5410048" cy="3219260"/>
           </a:xfrm>
           <a:prstGeom prst="roundRect">
             <a:avLst>
-              <a:gd name="adj" fmla="val 2020"/>
+              <a:gd name="adj" fmla="val 2840"/>
             </a:avLst>
           </a:prstGeom>
           <a:solidFill>
@@ -21754,7 +21754,7 @@
         </p:nvSpPr>
         <p:spPr>
           <a:xfrm>
-            <a:off x="6233008" y="1645920"/>
+            <a:off x="6233008" y="2299430"/>
             <a:ext cx="5410048" cy="73152"/>
           </a:xfrm>
           <a:prstGeom prst="rect">
@@ -21774,7 +21774,7 @@
         </p:nvSpPr>
         <p:spPr>
           <a:xfrm>
-            <a:off x="6461608" y="1920240"/>
+            <a:off x="6461608" y="2573750"/>
             <a:ext cx="457200" cy="457200"/>
           </a:xfrm>
           <a:prstGeom prst="roundRect">
@@ -21796,7 +21796,7 @@
         </p:nvSpPr>
         <p:spPr>
           <a:xfrm>
-            <a:off x="7055968" y="1920240"/>
+            <a:off x="7055968" y="2573750"/>
             <a:ext cx="4404208" cy="457200"/>
           </a:xfrm>
           <a:prstGeom prst="rect">
@@ -21832,8 +21832,8 @@
         </p:nvSpPr>
         <p:spPr>
           <a:xfrm>
-            <a:off x="6461608" y="2560320"/>
-            <a:ext cx="4952848" cy="3474720"/>
+            <a:off x="6461608" y="3213830"/>
+            <a:ext cx="4952848" cy="2167700"/>
           </a:xfrm>
           <a:prstGeom prst="rect">
             <a:avLst/>
@@ -21969,7 +21969,7 @@
         </p:blipFill>
         <p:spPr>
           <a:xfrm>
-            <a:off x="877824" y="2020824"/>
+            <a:off x="877824" y="2674334"/>
             <a:ext cx="256032" cy="256032"/>
           </a:xfrm>
           <a:prstGeom prst="rect">
@@ -21993,7 +21993,7 @@
         </p:blipFill>
         <p:spPr>
           <a:xfrm>
-            <a:off x="6562192" y="2020824"/>
+            <a:off x="6562192" y="2674334"/>
             <a:ext cx="256032" cy="256032"/>
           </a:xfrm>
           <a:prstGeom prst="rect">

</xml_diff>